<commit_message>
feat: Nepalcan order edit + RBAC + detail totals fix
- NepalcanOrder model: add trackingData + priceHistory fields
- Sync service: store full tracking snapshot, record price changes (sync + manual)
- Enrichment: persist trackingData for all active orders
- getOrderTracking: DB-only, overlays edited fields + priceHistory
- updateNepalcanOrder: push manual priceHistory on amount changes
- Detail page totals use updated DB totalAmount (includes shipping)
- RBAC: add nepalcan.orders-edit permission, gate PUT + pencil icon
- PermissionsSettingsPage: 'Edit Orders' checkbox
- Provider pricing routes + settings tab
- Delivery zones: per-action RBAC (view/manage)
- Removed chart comparison artifacts
</commit_message>
<xml_diff>
--- a/Weekly_Report_23_Jestha_2083.pptx
+++ b/Weekly_Report_23_Jestha_2083.pptx
@@ -4571,7 +4571,7 @@
         </p:blipFill>
         <p:spPr>
           <a:xfrm>
-            <a:off x="411480" y="1824770"/>
+            <a:off x="411480" y="2190750"/>
             <a:ext cx="6009220" cy="3931920"/>
           </a:xfrm>
           <a:prstGeom prst="rect">
@@ -4773,7 +4773,7 @@
         </p:blipFill>
         <p:spPr>
           <a:xfrm>
-            <a:off x="6420700" y="1866850"/>
+            <a:off x="6420700" y="2190750"/>
             <a:ext cx="5771300" cy="3931800"/>
           </a:xfrm>
           <a:prstGeom prst="rect">
@@ -8084,7 +8084,7 @@
                 <a:cs typeface="Play"/>
                 <a:sym typeface="Play"/>
               </a:rPr>
-              <a:t/>
+              <a:t>Total Vendors</a:t>
             </a:r>
             <a:endParaRPr sz="1300">
               <a:solidFill>
@@ -8113,7 +8113,7 @@
         </p:blipFill>
         <p:spPr>
           <a:xfrm>
-            <a:off x="411480" y="1824770"/>
+            <a:off x="411480" y="2190750"/>
             <a:ext cx="6009220" cy="3931920"/>
           </a:xfrm>
           <a:prstGeom prst="rect">
@@ -8315,7 +8315,7 @@
         </p:blipFill>
         <p:spPr>
           <a:xfrm>
-            <a:off x="6420700" y="1866850"/>
+            <a:off x="6420700" y="2190750"/>
             <a:ext cx="5771300" cy="3931800"/>
           </a:xfrm>
           <a:prstGeom prst="rect">
@@ -8371,7 +8371,7 @@
                 <a:cs typeface="Play"/>
                 <a:sym typeface="Play"/>
               </a:rPr>
-              <a:t/>
+              <a:t>Total Verified Vendors</a:t>
             </a:r>
             <a:endParaRPr b="1" sz="1300">
               <a:solidFill>
@@ -13303,7 +13303,7 @@
         </p:blipFill>
         <p:spPr>
           <a:xfrm>
-            <a:off x="713232" y="1600200"/>
+            <a:off x="713232" y="2190750"/>
             <a:ext cx="5486400" cy="3611880"/>
           </a:xfrm>
           <a:prstGeom prst="rect">
@@ -13413,7 +13413,7 @@
                 <a:cs typeface="Play"/>
                 <a:sym typeface="Play"/>
               </a:rPr>
-              <a:t>Total Specifications Added Trend</a:t>
+              <a:t>Daily Average Listings Trend</a:t>
             </a:r>
             <a:endParaRPr sz="1700">
               <a:solidFill>
@@ -13442,7 +13442,7 @@
         </p:blipFill>
         <p:spPr>
           <a:xfrm>
-            <a:off x="6812280" y="1600200"/>
+            <a:off x="6812280" y="2190750"/>
             <a:ext cx="4754880" cy="3611880"/>
           </a:xfrm>
           <a:prstGeom prst="rect">
@@ -13664,7 +13664,7 @@
                 <a:cs typeface="Play"/>
                 <a:sym typeface="Play"/>
               </a:rPr>
-              <a:t>Total Products Shown in Marketplace: —</a:t>
+              <a:t>Total Products Shown in Marketplace: 200</a:t>
             </a:r>
             <a:endParaRPr sz="1200">
               <a:solidFill>

</xml_diff>